<commit_message>
feat: add winner-grade localisation release gates
</commit_message>
<xml_diff>
--- a/submission/BhashaFix-Hackathon-Deck.pptx
+++ b/submission/BhashaFix-Hackathon-Deck.pptx
@@ -2,22 +2,22 @@
 <file path=ppt/presentation.xml><?xml version="1.0" encoding="utf-8"?>
 <p:presentation xmlns:p="http://schemas.openxmlformats.org/presentationml/2006/main">
   <p:sldMasterIdLst>
-    <p:sldMasterId xmlns:r="http://schemas.openxmlformats.org/officeDocument/2006/relationships" id="2147483648" r:id="Rd46fe9d8e021448b"/>
+    <p:sldMasterId xmlns:r="http://schemas.openxmlformats.org/officeDocument/2006/relationships" id="2147483648" r:id="Rf34a9cc449eb48a0"/>
   </p:sldMasterIdLst>
   <p:notesMasterIdLst>
-    <p:notesMasterId xmlns:r="http://schemas.openxmlformats.org/officeDocument/2006/relationships" r:id="Rb7cc68c1b6924d95"/>
+    <p:notesMasterId xmlns:r="http://schemas.openxmlformats.org/officeDocument/2006/relationships" r:id="R0d888b51592b47b5"/>
   </p:notesMasterIdLst>
   <p:sldIdLst>
-    <p:sldId xmlns:r="http://schemas.openxmlformats.org/officeDocument/2006/relationships" id="256" r:id="Rd6e2f048e2dc4be4"/>
-    <p:sldId xmlns:r="http://schemas.openxmlformats.org/officeDocument/2006/relationships" id="257" r:id="R33ef762665a64032"/>
-    <p:sldId xmlns:r="http://schemas.openxmlformats.org/officeDocument/2006/relationships" id="258" r:id="R24e83c6e91414a91"/>
-    <p:sldId xmlns:r="http://schemas.openxmlformats.org/officeDocument/2006/relationships" id="259" r:id="R494e29811dd547ed"/>
-    <p:sldId xmlns:r="http://schemas.openxmlformats.org/officeDocument/2006/relationships" id="260" r:id="R2529324b5f324e6b"/>
-    <p:sldId xmlns:r="http://schemas.openxmlformats.org/officeDocument/2006/relationships" id="261" r:id="R265044cc7a174a93"/>
-    <p:sldId xmlns:r="http://schemas.openxmlformats.org/officeDocument/2006/relationships" id="262" r:id="R1423e1bf18694b3a"/>
-    <p:sldId xmlns:r="http://schemas.openxmlformats.org/officeDocument/2006/relationships" id="263" r:id="R9c70680939d34684"/>
-    <p:sldId xmlns:r="http://schemas.openxmlformats.org/officeDocument/2006/relationships" id="264" r:id="R627592aca4f64b30"/>
-    <p:sldId xmlns:r="http://schemas.openxmlformats.org/officeDocument/2006/relationships" id="265" r:id="R929b09dae39949f4"/>
+    <p:sldId xmlns:r="http://schemas.openxmlformats.org/officeDocument/2006/relationships" id="256" r:id="Rb483c422a3074347"/>
+    <p:sldId xmlns:r="http://schemas.openxmlformats.org/officeDocument/2006/relationships" id="257" r:id="R8143551bd995461d"/>
+    <p:sldId xmlns:r="http://schemas.openxmlformats.org/officeDocument/2006/relationships" id="258" r:id="R67a58db635cb4cbd"/>
+    <p:sldId xmlns:r="http://schemas.openxmlformats.org/officeDocument/2006/relationships" id="259" r:id="R340e772ba044450c"/>
+    <p:sldId xmlns:r="http://schemas.openxmlformats.org/officeDocument/2006/relationships" id="260" r:id="Rf07028f518c54e4c"/>
+    <p:sldId xmlns:r="http://schemas.openxmlformats.org/officeDocument/2006/relationships" id="261" r:id="R64b57b3617eb48b9"/>
+    <p:sldId xmlns:r="http://schemas.openxmlformats.org/officeDocument/2006/relationships" id="262" r:id="R7694ac62762c4218"/>
+    <p:sldId xmlns:r="http://schemas.openxmlformats.org/officeDocument/2006/relationships" id="263" r:id="R3d526ec57d914f38"/>
+    <p:sldId xmlns:r="http://schemas.openxmlformats.org/officeDocument/2006/relationships" id="264" r:id="R483fb221306249ad"/>
+    <p:sldId xmlns:r="http://schemas.openxmlformats.org/officeDocument/2006/relationships" id="265" r:id="R9a7442eae370443d"/>
   </p:sldIdLst>
   <p:sldSz cx="12192000" cy="6858000"/>
   <p:notesSz cx="6858000" cy="9144000"/>
@@ -456,7 +456,12 @@
           </a:p>
           <a:p xmlns:a="http://schemas.openxmlformats.org/drawingml/2006/main">
             <a:r>
-              <a:t>- BhashaFix deterministic engine and repair proof, generated 29 July 2026.</a:t>
+              <a:t>- BhashaFix deterministic engine and release receipt, generated 30 July 2026.</a:t>
+            </a:r>
+          </a:p>
+          <a:p xmlns:a="http://schemas.openxmlformats.org/drawingml/2006/main">
+            <a:r>
+              <a:t>- Product claims are implemented and tested in the local BhashaFix repository.</a:t>
             </a:r>
           </a:p>
           <a:p xmlns:a="http://schemas.openxmlformats.org/drawingml/2006/main">
@@ -536,7 +541,12 @@
           </a:p>
           <a:p xmlns:a="http://schemas.openxmlformats.org/drawingml/2006/main">
             <a:r>
-              <a:t>- BhashaFix deterministic engine and repair proof, generated 29 July 2026.</a:t>
+              <a:t>- BhashaFix deterministic engine and release receipt, generated 30 July 2026.</a:t>
+            </a:r>
+          </a:p>
+          <a:p xmlns:a="http://schemas.openxmlformats.org/drawingml/2006/main">
+            <a:r>
+              <a:t>- Product claims are implemented and tested in the local BhashaFix repository.</a:t>
             </a:r>
           </a:p>
           <a:p xmlns:a="http://schemas.openxmlformats.org/drawingml/2006/main">
@@ -616,7 +626,12 @@
           </a:p>
           <a:p xmlns:a="http://schemas.openxmlformats.org/drawingml/2006/main">
             <a:r>
-              <a:t>- BhashaFix deterministic engine and repair proof, generated 29 July 2026.</a:t>
+              <a:t>- BhashaFix deterministic engine and release receipt, generated 30 July 2026.</a:t>
+            </a:r>
+          </a:p>
+          <a:p xmlns:a="http://schemas.openxmlformats.org/drawingml/2006/main">
+            <a:r>
+              <a:t>- Product claims are implemented and tested in the local BhashaFix repository.</a:t>
             </a:r>
           </a:p>
           <a:p xmlns:a="http://schemas.openxmlformats.org/drawingml/2006/main">
@@ -696,12 +711,17 @@
           </a:p>
           <a:p xmlns:a="http://schemas.openxmlformats.org/drawingml/2006/main">
             <a:r>
-              <a:t>- BhashaFix deterministic engine and repair proof, generated 29 July 2026.</a:t>
+              <a:t>- BhashaFix deterministic engine and release receipt, generated 30 July 2026.</a:t>
             </a:r>
           </a:p>
           <a:p xmlns:a="http://schemas.openxmlformats.org/drawingml/2006/main">
             <a:r>
               <a:t>- Product claims are implemented and tested in the local BhashaFix repository.</a:t>
+            </a:r>
+          </a:p>
+          <a:p xmlns:a="http://schemas.openxmlformats.org/drawingml/2006/main">
+            <a:r>
+              <a:t>- No external visual asset used.</a:t>
             </a:r>
           </a:p>
         </p:txBody>
@@ -776,7 +796,12 @@
           </a:p>
           <a:p xmlns:a="http://schemas.openxmlformats.org/drawingml/2006/main">
             <a:r>
-              <a:t>- BhashaFix deterministic engine and repair proof, generated 29 July 2026.</a:t>
+              <a:t>- BhashaFix deterministic engine and release receipt, generated 30 July 2026.</a:t>
+            </a:r>
+          </a:p>
+          <a:p xmlns:a="http://schemas.openxmlformats.org/drawingml/2006/main">
+            <a:r>
+              <a:t>- Product claims are implemented and tested in the local BhashaFix repository.</a:t>
             </a:r>
           </a:p>
           <a:p xmlns:a="http://schemas.openxmlformats.org/drawingml/2006/main">
@@ -856,12 +881,17 @@
           </a:p>
           <a:p xmlns:a="http://schemas.openxmlformats.org/drawingml/2006/main">
             <a:r>
-              <a:t>- BhashaFix deterministic engine and repair proof, generated 29 July 2026.</a:t>
-            </a:r>
-          </a:p>
-          <a:p xmlns:a="http://schemas.openxmlformats.org/drawingml/2006/main">
-            <a:r>
-              <a:t>- Product claims are implemented and tested in the local BhashaFix repository.</a:t>
+              <a:t>- BhashaFix deterministic engine and release receipt, generated 30 July 2026.</a:t>
+            </a:r>
+          </a:p>
+          <a:p xmlns:a="http://schemas.openxmlformats.org/drawingml/2006/main">
+            <a:r>
+              <a:t>- Official MCP Inspector and MCPC receipts: artifacts/mcp-inspector-receipt.json and artifacts/mcpc-smoke/receipt.json.</a:t>
+            </a:r>
+          </a:p>
+          <a:p xmlns:a="http://schemas.openxmlformats.org/drawingml/2006/main">
+            <a:r>
+              <a:t>- No external visual asset used.</a:t>
             </a:r>
           </a:p>
         </p:txBody>
@@ -936,7 +966,12 @@
           </a:p>
           <a:p xmlns:a="http://schemas.openxmlformats.org/drawingml/2006/main">
             <a:r>
-              <a:t>- BhashaFix deterministic engine and repair proof, generated 29 July 2026.</a:t>
+              <a:t>- BhashaFix deterministic engine and release receipt, generated 30 July 2026.</a:t>
+            </a:r>
+          </a:p>
+          <a:p xmlns:a="http://schemas.openxmlformats.org/drawingml/2006/main">
+            <a:r>
+              <a:t>- Product claims are implemented and tested in the local BhashaFix repository.</a:t>
             </a:r>
           </a:p>
           <a:p xmlns:a="http://schemas.openxmlformats.org/drawingml/2006/main">
@@ -1016,12 +1051,17 @@
           </a:p>
           <a:p xmlns:a="http://schemas.openxmlformats.org/drawingml/2006/main">
             <a:r>
-              <a:t>- BhashaFix deterministic engine and repair proof, generated 29 July 2026.</a:t>
+              <a:t>- BhashaFix deterministic engine and release receipt, generated 30 July 2026.</a:t>
             </a:r>
           </a:p>
           <a:p xmlns:a="http://schemas.openxmlformats.org/drawingml/2006/main">
             <a:r>
               <a:t>- Product claims are implemented and tested in the local BhashaFix repository.</a:t>
+            </a:r>
+          </a:p>
+          <a:p xmlns:a="http://schemas.openxmlformats.org/drawingml/2006/main">
+            <a:r>
+              <a:t>- No external visual asset used.</a:t>
             </a:r>
           </a:p>
         </p:txBody>
@@ -1096,7 +1136,12 @@
           </a:p>
           <a:p xmlns:a="http://schemas.openxmlformats.org/drawingml/2006/main">
             <a:r>
-              <a:t>- BhashaFix deterministic engine and repair proof, generated 29 July 2026.</a:t>
+              <a:t>- BhashaFix deterministic engine and release receipt, generated 30 July 2026.</a:t>
+            </a:r>
+          </a:p>
+          <a:p xmlns:a="http://schemas.openxmlformats.org/drawingml/2006/main">
+            <a:r>
+              <a:t>- Product claims are implemented and tested in the local BhashaFix repository.</a:t>
             </a:r>
           </a:p>
           <a:p xmlns:a="http://schemas.openxmlformats.org/drawingml/2006/main">
@@ -1176,12 +1221,17 @@
           </a:p>
           <a:p xmlns:a="http://schemas.openxmlformats.org/drawingml/2006/main">
             <a:r>
-              <a:t>- BhashaFix deterministic engine and repair proof, generated 29 July 2026.</a:t>
+              <a:t>- BhashaFix deterministic engine and release receipt, generated 30 July 2026.</a:t>
             </a:r>
           </a:p>
           <a:p xmlns:a="http://schemas.openxmlformats.org/drawingml/2006/main">
             <a:r>
               <a:t>- Product claims are implemented and tested in the local BhashaFix repository.</a:t>
+            </a:r>
+          </a:p>
+          <a:p xmlns:a="http://schemas.openxmlformats.org/drawingml/2006/main">
+            <a:r>
+              <a:t>- No external visual asset used.</a:t>
             </a:r>
           </a:p>
         </p:txBody>
@@ -1249,7 +1299,7 @@
   </p:cSld>
   <p:clrMap bg1="lt1" tx1="dk1" bg2="lt2" tx2="dk2" accent1="accent1" accent2="accent2" accent3="accent3" accent4="accent4" accent5="accent5" accent6="accent6" hlink="hlink" folHlink="folHlink"/>
   <p:sldLayoutIdLst>
-    <p:sldLayoutId xmlns:r="http://schemas.openxmlformats.org/officeDocument/2006/relationships" id="2147483649" r:id="R503552a7a8b84e15"/>
+    <p:sldLayoutId xmlns:r="http://schemas.openxmlformats.org/officeDocument/2006/relationships" id="2147483649" r:id="Rda390392cc6941b8"/>
   </p:sldLayoutIdLst>
   <p:txStyles>
     <p:titleStyle>
@@ -1804,7 +1854,7 @@
           <p:nvPr/>
         </p:nvPicPr>
         <p:blipFill>
-          <a:blip xmlns:r="http://schemas.openxmlformats.org/officeDocument/2006/relationships" xmlns:a="http://schemas.openxmlformats.org/drawingml/2006/main" r:embed="R98832e9131f346a1"/>
+          <a:blip xmlns:r="http://schemas.openxmlformats.org/officeDocument/2006/relationships" xmlns:a="http://schemas.openxmlformats.org/drawingml/2006/main" r:embed="Rbc7432cf9ad44a29"/>
           <a:srcRect xmlns:a="http://schemas.openxmlformats.org/drawingml/2006/main" l="65000" t="0" r="0" b="0"/>
           <a:stretch xmlns:a="http://schemas.openxmlformats.org/drawingml/2006/main">
             <a:fillRect l="0" t="0" r="0" b="0"/>
@@ -2243,7 +2293,7 @@
           <p:nvPr/>
         </p:nvPicPr>
         <p:blipFill>
-          <a:blip xmlns:r="http://schemas.openxmlformats.org/officeDocument/2006/relationships" xmlns:a="http://schemas.openxmlformats.org/drawingml/2006/main" r:embed="Ra02b16ca829440a6"/>
+          <a:blip xmlns:r="http://schemas.openxmlformats.org/officeDocument/2006/relationships" xmlns:a="http://schemas.openxmlformats.org/drawingml/2006/main" r:embed="R669842d052d24b7d"/>
           <a:srcRect xmlns:a="http://schemas.openxmlformats.org/drawingml/2006/main" l="65000" t="0" r="0" b="0"/>
           <a:stretch xmlns:a="http://schemas.openxmlformats.org/drawingml/2006/main">
             <a:fillRect l="0" t="0" r="0" b="0"/>
@@ -3347,7 +3397,7 @@
           <p:nvPr/>
         </p:nvPicPr>
         <p:blipFill>
-          <a:blip xmlns:r="http://schemas.openxmlformats.org/officeDocument/2006/relationships" xmlns:a="http://schemas.openxmlformats.org/drawingml/2006/main" r:embed="R83ea43ae5a9a4f21"/>
+          <a:blip xmlns:r="http://schemas.openxmlformats.org/officeDocument/2006/relationships" xmlns:a="http://schemas.openxmlformats.org/drawingml/2006/main" r:embed="R0e88ea2c879a41e5"/>
           <a:srcRect xmlns:a="http://schemas.openxmlformats.org/drawingml/2006/main" l="0" t="10366" r="0" b="10366"/>
           <a:stretch xmlns:a="http://schemas.openxmlformats.org/drawingml/2006/main">
             <a:fillRect l="0" t="0" r="0" b="0"/>
@@ -4378,7 +4428,7 @@
           <p:nvPr/>
         </p:nvPicPr>
         <p:blipFill>
-          <a:blip xmlns:r="http://schemas.openxmlformats.org/officeDocument/2006/relationships" xmlns:a="http://schemas.openxmlformats.org/drawingml/2006/main" r:embed="R9d876485c2db4486"/>
+          <a:blip xmlns:r="http://schemas.openxmlformats.org/officeDocument/2006/relationships" xmlns:a="http://schemas.openxmlformats.org/drawingml/2006/main" r:embed="R7bac4c1b98a749bc"/>
           <a:srcRect xmlns:a="http://schemas.openxmlformats.org/drawingml/2006/main" l="0" t="6924" r="0" b="6924"/>
           <a:stretch xmlns:a="http://schemas.openxmlformats.org/drawingml/2006/main">
             <a:fillRect l="0" t="0" r="0" b="0"/>
@@ -6279,7 +6329,7 @@
                   <a:srgbClr val="B9AFC8"/>
                 </a:solidFill>
               </a:rPr>
-              <a:t>15 tools</a:t>
+              <a:t>18 tools</a:t>
             </a:r>
           </a:p>
           <a:p xmlns:a="http://schemas.openxmlformats.org/drawingml/2006/main">
@@ -6297,7 +6347,7 @@
                   <a:srgbClr val="B9AFC8"/>
                 </a:solidFill>
               </a:rPr>
-              <a:t>strict schemas</a:t>
+              <a:t>Inspector + MCPC</a:t>
             </a:r>
           </a:p>
         </p:txBody>
@@ -7599,7 +7649,7 @@
           <p:nvPr/>
         </p:nvPicPr>
         <p:blipFill>
-          <a:blip xmlns:r="http://schemas.openxmlformats.org/officeDocument/2006/relationships" xmlns:a="http://schemas.openxmlformats.org/drawingml/2006/main" r:embed="R29281b1a0ec044a1"/>
+          <a:blip xmlns:r="http://schemas.openxmlformats.org/officeDocument/2006/relationships" xmlns:a="http://schemas.openxmlformats.org/drawingml/2006/main" r:embed="R1cbab173572f4985"/>
           <a:srcRect xmlns:a="http://schemas.openxmlformats.org/drawingml/2006/main" l="0" t="51" r="0" b="51"/>
           <a:stretch xmlns:a="http://schemas.openxmlformats.org/drawingml/2006/main">
             <a:fillRect l="0" t="0" r="0" b="0"/>
@@ -9488,7 +9538,7 @@
           <p:nvPr/>
         </p:nvPicPr>
         <p:blipFill>
-          <a:blip xmlns:r="http://schemas.openxmlformats.org/officeDocument/2006/relationships" xmlns:a="http://schemas.openxmlformats.org/drawingml/2006/main" r:embed="Rd6b5830682e64ec8"/>
+          <a:blip xmlns:r="http://schemas.openxmlformats.org/officeDocument/2006/relationships" xmlns:a="http://schemas.openxmlformats.org/drawingml/2006/main" r:embed="R7c1804e7e1ff4ce5"/>
           <a:srcRect xmlns:a="http://schemas.openxmlformats.org/drawingml/2006/main" l="0" t="3275" r="0" b="3275"/>
           <a:stretch xmlns:a="http://schemas.openxmlformats.org/drawingml/2006/main">
             <a:fillRect l="0" t="0" r="0" b="0"/>

</xml_diff>

<commit_message>
feat: make public scans real and evidence-first
</commit_message>
<xml_diff>
--- a/submission/BhashaFix-Hackathon-Deck.pptx
+++ b/submission/BhashaFix-Hackathon-Deck.pptx
@@ -2,22 +2,22 @@
 <file path=ppt/presentation.xml><?xml version="1.0" encoding="utf-8"?>
 <p:presentation xmlns:p="http://schemas.openxmlformats.org/presentationml/2006/main">
   <p:sldMasterIdLst>
-    <p:sldMasterId xmlns:r="http://schemas.openxmlformats.org/officeDocument/2006/relationships" id="2147483648" r:id="Rf34a9cc449eb48a0"/>
+    <p:sldMasterId xmlns:r="http://schemas.openxmlformats.org/officeDocument/2006/relationships" id="2147483648" r:id="Rb895159d3f614a56"/>
   </p:sldMasterIdLst>
   <p:notesMasterIdLst>
-    <p:notesMasterId xmlns:r="http://schemas.openxmlformats.org/officeDocument/2006/relationships" r:id="R0d888b51592b47b5"/>
+    <p:notesMasterId xmlns:r="http://schemas.openxmlformats.org/officeDocument/2006/relationships" r:id="Rd6cc8de7a15c4aff"/>
   </p:notesMasterIdLst>
   <p:sldIdLst>
-    <p:sldId xmlns:r="http://schemas.openxmlformats.org/officeDocument/2006/relationships" id="256" r:id="Rb483c422a3074347"/>
-    <p:sldId xmlns:r="http://schemas.openxmlformats.org/officeDocument/2006/relationships" id="257" r:id="R8143551bd995461d"/>
-    <p:sldId xmlns:r="http://schemas.openxmlformats.org/officeDocument/2006/relationships" id="258" r:id="R67a58db635cb4cbd"/>
-    <p:sldId xmlns:r="http://schemas.openxmlformats.org/officeDocument/2006/relationships" id="259" r:id="R340e772ba044450c"/>
-    <p:sldId xmlns:r="http://schemas.openxmlformats.org/officeDocument/2006/relationships" id="260" r:id="Rf07028f518c54e4c"/>
-    <p:sldId xmlns:r="http://schemas.openxmlformats.org/officeDocument/2006/relationships" id="261" r:id="R64b57b3617eb48b9"/>
-    <p:sldId xmlns:r="http://schemas.openxmlformats.org/officeDocument/2006/relationships" id="262" r:id="R7694ac62762c4218"/>
-    <p:sldId xmlns:r="http://schemas.openxmlformats.org/officeDocument/2006/relationships" id="263" r:id="R3d526ec57d914f38"/>
-    <p:sldId xmlns:r="http://schemas.openxmlformats.org/officeDocument/2006/relationships" id="264" r:id="R483fb221306249ad"/>
-    <p:sldId xmlns:r="http://schemas.openxmlformats.org/officeDocument/2006/relationships" id="265" r:id="R9a7442eae370443d"/>
+    <p:sldId xmlns:r="http://schemas.openxmlformats.org/officeDocument/2006/relationships" id="256" r:id="Ra75b3ef9477a4700"/>
+    <p:sldId xmlns:r="http://schemas.openxmlformats.org/officeDocument/2006/relationships" id="257" r:id="R8dcc4fcccefc4ebb"/>
+    <p:sldId xmlns:r="http://schemas.openxmlformats.org/officeDocument/2006/relationships" id="258" r:id="Rc1eab499baa94801"/>
+    <p:sldId xmlns:r="http://schemas.openxmlformats.org/officeDocument/2006/relationships" id="259" r:id="Ra228d850581e4f38"/>
+    <p:sldId xmlns:r="http://schemas.openxmlformats.org/officeDocument/2006/relationships" id="260" r:id="Rd963bdee4f154855"/>
+    <p:sldId xmlns:r="http://schemas.openxmlformats.org/officeDocument/2006/relationships" id="261" r:id="R8c5de195fd8c4d86"/>
+    <p:sldId xmlns:r="http://schemas.openxmlformats.org/officeDocument/2006/relationships" id="262" r:id="Rafd52cbb34ac4ad0"/>
+    <p:sldId xmlns:r="http://schemas.openxmlformats.org/officeDocument/2006/relationships" id="263" r:id="Rb74a657b095c4827"/>
+    <p:sldId xmlns:r="http://schemas.openxmlformats.org/officeDocument/2006/relationships" id="264" r:id="Rf7e1a8e906304f9f"/>
+    <p:sldId xmlns:r="http://schemas.openxmlformats.org/officeDocument/2006/relationships" id="265" r:id="Re83fc4a25b684bbe"/>
   </p:sldIdLst>
   <p:sldSz cx="12192000" cy="6858000"/>
   <p:notesSz cx="6858000" cy="9144000"/>
@@ -966,17 +966,27 @@
           </a:p>
           <a:p xmlns:a="http://schemas.openxmlformats.org/drawingml/2006/main">
             <a:r>
-              <a:t>- BhashaFix deterministic engine and release receipt, generated 30 July 2026.</a:t>
-            </a:r>
-          </a:p>
-          <a:p xmlns:a="http://schemas.openxmlformats.org/drawingml/2006/main">
-            <a:r>
-              <a:t>- Product claims are implemented and tested in the local BhashaFix repository.</a:t>
-            </a:r>
-          </a:p>
-          <a:p xmlns:a="http://schemas.openxmlformats.org/drawingml/2006/main">
-            <a:r>
-              <a:t>- Actual local Playwright/browser screenshot: submission/screenshots/05-proof-report.png.</a:t>
+              <a:t>- BhashaFix deterministic AtlasPay release proof, generated 30 July 2026.</a:t>
+            </a:r>
+          </a:p>
+          <a:p xmlns:a="http://schemas.openxmlformats.org/drawingml/2006/main">
+            <a:r>
+              <a:t>- Actual local Playwright/browser proof: submission/screenshots/05-proof-report.png.</a:t>
+            </a:r>
+          </a:p>
+          <a:p xmlns:a="http://schemas.openxmlformats.org/drawingml/2006/main">
+            <a:r>
+              <a:t>- Live public target scanned on 30 July 2026: https://www.mozilla.org/.</a:t>
+            </a:r>
+          </a:p>
+          <a:p xmlns:a="http://schemas.openxmlformats.org/drawingml/2006/main">
+            <a:r>
+              <a:t>- Live BhashaFix scan screenshot: submission/screenshots/10-live-public-product-proof.png.</a:t>
+            </a:r>
+          </a:p>
+          <a:p xmlns:a="http://schemas.openxmlformats.org/drawingml/2006/main">
+            <a:r>
+              <a:t>- Live scan receipt: artifacts/live-public-scan-receipt.json.</a:t>
             </a:r>
           </a:p>
         </p:txBody>
@@ -1299,7 +1309,7 @@
   </p:cSld>
   <p:clrMap bg1="lt1" tx1="dk1" bg2="lt2" tx2="dk2" accent1="accent1" accent2="accent2" accent3="accent3" accent4="accent4" accent5="accent5" accent6="accent6" hlink="hlink" folHlink="folHlink"/>
   <p:sldLayoutIdLst>
-    <p:sldLayoutId xmlns:r="http://schemas.openxmlformats.org/officeDocument/2006/relationships" id="2147483649" r:id="Rda390392cc6941b8"/>
+    <p:sldLayoutId xmlns:r="http://schemas.openxmlformats.org/officeDocument/2006/relationships" id="2147483649" r:id="R9906132b5c65440b"/>
   </p:sldLayoutIdLst>
   <p:txStyles>
     <p:titleStyle>
@@ -1854,7 +1864,7 @@
           <p:nvPr/>
         </p:nvPicPr>
         <p:blipFill>
-          <a:blip xmlns:r="http://schemas.openxmlformats.org/officeDocument/2006/relationships" xmlns:a="http://schemas.openxmlformats.org/drawingml/2006/main" r:embed="Rbc7432cf9ad44a29"/>
+          <a:blip xmlns:r="http://schemas.openxmlformats.org/officeDocument/2006/relationships" xmlns:a="http://schemas.openxmlformats.org/drawingml/2006/main" r:embed="R0bb77b4e910b437b"/>
           <a:srcRect xmlns:a="http://schemas.openxmlformats.org/drawingml/2006/main" l="65000" t="0" r="0" b="0"/>
           <a:stretch xmlns:a="http://schemas.openxmlformats.org/drawingml/2006/main">
             <a:fillRect l="0" t="0" r="0" b="0"/>
@@ -2293,7 +2303,7 @@
           <p:nvPr/>
         </p:nvPicPr>
         <p:blipFill>
-          <a:blip xmlns:r="http://schemas.openxmlformats.org/officeDocument/2006/relationships" xmlns:a="http://schemas.openxmlformats.org/drawingml/2006/main" r:embed="R669842d052d24b7d"/>
+          <a:blip xmlns:r="http://schemas.openxmlformats.org/officeDocument/2006/relationships" xmlns:a="http://schemas.openxmlformats.org/drawingml/2006/main" r:embed="R75659b9cd7cd4baa"/>
           <a:srcRect xmlns:a="http://schemas.openxmlformats.org/drawingml/2006/main" l="65000" t="0" r="0" b="0"/>
           <a:stretch xmlns:a="http://schemas.openxmlformats.org/drawingml/2006/main">
             <a:fillRect l="0" t="0" r="0" b="0"/>
@@ -3397,7 +3407,7 @@
           <p:nvPr/>
         </p:nvPicPr>
         <p:blipFill>
-          <a:blip xmlns:r="http://schemas.openxmlformats.org/officeDocument/2006/relationships" xmlns:a="http://schemas.openxmlformats.org/drawingml/2006/main" r:embed="R0e88ea2c879a41e5"/>
+          <a:blip xmlns:r="http://schemas.openxmlformats.org/officeDocument/2006/relationships" xmlns:a="http://schemas.openxmlformats.org/drawingml/2006/main" r:embed="R72a69dfa2eab42ab"/>
           <a:srcRect xmlns:a="http://schemas.openxmlformats.org/drawingml/2006/main" l="0" t="10366" r="0" b="10366"/>
           <a:stretch xmlns:a="http://schemas.openxmlformats.org/drawingml/2006/main">
             <a:fillRect l="0" t="0" r="0" b="0"/>
@@ -4428,7 +4438,7 @@
           <p:nvPr/>
         </p:nvPicPr>
         <p:blipFill>
-          <a:blip xmlns:r="http://schemas.openxmlformats.org/officeDocument/2006/relationships" xmlns:a="http://schemas.openxmlformats.org/drawingml/2006/main" r:embed="R7bac4c1b98a749bc"/>
+          <a:blip xmlns:r="http://schemas.openxmlformats.org/officeDocument/2006/relationships" xmlns:a="http://schemas.openxmlformats.org/drawingml/2006/main" r:embed="R8f934fbbea3e4345"/>
           <a:srcRect xmlns:a="http://schemas.openxmlformats.org/drawingml/2006/main" l="0" t="6924" r="0" b="6924"/>
           <a:stretch xmlns:a="http://schemas.openxmlformats.org/drawingml/2006/main">
             <a:fillRect l="0" t="0" r="0" b="0"/>
@@ -7125,7 +7135,7 @@
                   <a:srgbClr val="D8B4FE"/>
                 </a:solidFill>
               </a:rPr>
-              <a:t>THE VERIFIED PROOF</a:t>
+              <a:t>TWO REAL PROOF MODES</a:t>
             </a:r>
           </a:p>
         </p:txBody>
@@ -7329,7 +7339,7 @@
                   <a:srgbClr val="FFF8E8"/>
                 </a:solidFill>
               </a:rPr>
-              <a:t>blocking failures</a:t>
+              <a:t>AtlasPay blocking failures</a:t>
             </a:r>
           </a:p>
         </p:txBody>
@@ -7380,7 +7390,7 @@
                   <a:srgbClr val="B9AFC8"/>
                 </a:solidFill>
               </a:rPr>
-              <a:t>Source regression</a:t>
+              <a:t>Mozilla routes checked</a:t>
             </a:r>
           </a:p>
         </p:txBody>
@@ -7431,7 +7441,7 @@
                   <a:srgbClr val="86EFAC"/>
                 </a:solidFill>
               </a:rPr>
-              <a:t>PASS</a:t>
+              <a:t>5</a:t>
             </a:r>
           </a:p>
         </p:txBody>
@@ -7482,7 +7492,7 @@
                   <a:srgbClr val="B9AFC8"/>
                 </a:solidFill>
               </a:rPr>
-              <a:t>Changed source files</a:t>
+              <a:t>Mozilla strings extracted</a:t>
             </a:r>
           </a:p>
         </p:txBody>
@@ -7533,7 +7543,7 @@
                   <a:srgbClr val="FFF8E8"/>
                 </a:solidFill>
               </a:rPr>
-              <a:t>3</a:t>
+              <a:t>778</a:t>
             </a:r>
           </a:p>
         </p:txBody>
@@ -7649,7 +7659,7 @@
           <p:nvPr/>
         </p:nvPicPr>
         <p:blipFill>
-          <a:blip xmlns:r="http://schemas.openxmlformats.org/officeDocument/2006/relationships" xmlns:a="http://schemas.openxmlformats.org/drawingml/2006/main" r:embed="R1cbab173572f4985"/>
+          <a:blip xmlns:r="http://schemas.openxmlformats.org/officeDocument/2006/relationships" xmlns:a="http://schemas.openxmlformats.org/drawingml/2006/main" r:embed="R5c738a9e02c546f3"/>
           <a:srcRect xmlns:a="http://schemas.openxmlformats.org/drawingml/2006/main" l="0" t="51" r="0" b="51"/>
           <a:stretch xmlns:a="http://schemas.openxmlformats.org/drawingml/2006/main">
             <a:fillRect l="0" t="0" r="0" b="0"/>
@@ -9538,7 +9548,7 @@
           <p:nvPr/>
         </p:nvPicPr>
         <p:blipFill>
-          <a:blip xmlns:r="http://schemas.openxmlformats.org/officeDocument/2006/relationships" xmlns:a="http://schemas.openxmlformats.org/drawingml/2006/main" r:embed="R7c1804e7e1ff4ce5"/>
+          <a:blip xmlns:r="http://schemas.openxmlformats.org/officeDocument/2006/relationships" xmlns:a="http://schemas.openxmlformats.org/drawingml/2006/main" r:embed="Rc1738b4375ed4339"/>
           <a:srcRect xmlns:a="http://schemas.openxmlformats.org/drawingml/2006/main" l="0" t="3275" r="0" b="3275"/>
           <a:stretch xmlns:a="http://schemas.openxmlformats.org/drawingml/2006/main">
             <a:fillRect l="0" t="0" r="0" b="0"/>

</xml_diff>

<commit_message>
docs: prepare winner-grade open-source release
</commit_message>
<xml_diff>
--- a/submission/BhashaFix-Hackathon-Deck.pptx
+++ b/submission/BhashaFix-Hackathon-Deck.pptx
@@ -2,22 +2,22 @@
 <file path=ppt/presentation.xml><?xml version="1.0" encoding="utf-8"?>
 <p:presentation xmlns:p="http://schemas.openxmlformats.org/presentationml/2006/main">
   <p:sldMasterIdLst>
-    <p:sldMasterId xmlns:r="http://schemas.openxmlformats.org/officeDocument/2006/relationships" id="2147483648" r:id="Rb895159d3f614a56"/>
+    <p:sldMasterId xmlns:r="http://schemas.openxmlformats.org/officeDocument/2006/relationships" id="2147483648" r:id="R0e18c3f983c14cb2"/>
   </p:sldMasterIdLst>
   <p:notesMasterIdLst>
-    <p:notesMasterId xmlns:r="http://schemas.openxmlformats.org/officeDocument/2006/relationships" r:id="Rd6cc8de7a15c4aff"/>
+    <p:notesMasterId xmlns:r="http://schemas.openxmlformats.org/officeDocument/2006/relationships" r:id="R83609fbec64a4fa2"/>
   </p:notesMasterIdLst>
   <p:sldIdLst>
-    <p:sldId xmlns:r="http://schemas.openxmlformats.org/officeDocument/2006/relationships" id="256" r:id="Ra75b3ef9477a4700"/>
-    <p:sldId xmlns:r="http://schemas.openxmlformats.org/officeDocument/2006/relationships" id="257" r:id="R8dcc4fcccefc4ebb"/>
-    <p:sldId xmlns:r="http://schemas.openxmlformats.org/officeDocument/2006/relationships" id="258" r:id="Rc1eab499baa94801"/>
-    <p:sldId xmlns:r="http://schemas.openxmlformats.org/officeDocument/2006/relationships" id="259" r:id="Ra228d850581e4f38"/>
-    <p:sldId xmlns:r="http://schemas.openxmlformats.org/officeDocument/2006/relationships" id="260" r:id="Rd963bdee4f154855"/>
-    <p:sldId xmlns:r="http://schemas.openxmlformats.org/officeDocument/2006/relationships" id="261" r:id="R8c5de195fd8c4d86"/>
-    <p:sldId xmlns:r="http://schemas.openxmlformats.org/officeDocument/2006/relationships" id="262" r:id="Rafd52cbb34ac4ad0"/>
-    <p:sldId xmlns:r="http://schemas.openxmlformats.org/officeDocument/2006/relationships" id="263" r:id="Rb74a657b095c4827"/>
-    <p:sldId xmlns:r="http://schemas.openxmlformats.org/officeDocument/2006/relationships" id="264" r:id="Rf7e1a8e906304f9f"/>
-    <p:sldId xmlns:r="http://schemas.openxmlformats.org/officeDocument/2006/relationships" id="265" r:id="Re83fc4a25b684bbe"/>
+    <p:sldId xmlns:r="http://schemas.openxmlformats.org/officeDocument/2006/relationships" id="256" r:id="R8900841a319445ad"/>
+    <p:sldId xmlns:r="http://schemas.openxmlformats.org/officeDocument/2006/relationships" id="257" r:id="R615662294ac3440e"/>
+    <p:sldId xmlns:r="http://schemas.openxmlformats.org/officeDocument/2006/relationships" id="258" r:id="R614c3c4f55764fea"/>
+    <p:sldId xmlns:r="http://schemas.openxmlformats.org/officeDocument/2006/relationships" id="259" r:id="R37c4e46daebb45d7"/>
+    <p:sldId xmlns:r="http://schemas.openxmlformats.org/officeDocument/2006/relationships" id="260" r:id="R88e923a504044335"/>
+    <p:sldId xmlns:r="http://schemas.openxmlformats.org/officeDocument/2006/relationships" id="261" r:id="Rcfb546134cad49ad"/>
+    <p:sldId xmlns:r="http://schemas.openxmlformats.org/officeDocument/2006/relationships" id="262" r:id="Rcd6fdc4b2f424d3d"/>
+    <p:sldId xmlns:r="http://schemas.openxmlformats.org/officeDocument/2006/relationships" id="263" r:id="Rc2820453587a4691"/>
+    <p:sldId xmlns:r="http://schemas.openxmlformats.org/officeDocument/2006/relationships" id="264" r:id="Rfa23f25385524fdb"/>
+    <p:sldId xmlns:r="http://schemas.openxmlformats.org/officeDocument/2006/relationships" id="265" r:id="R6316bd6789b44711"/>
   </p:sldIdLst>
   <p:sldSz cx="12192000" cy="6858000"/>
   <p:notesSz cx="6858000" cy="9144000"/>
@@ -1309,7 +1309,7 @@
   </p:cSld>
   <p:clrMap bg1="lt1" tx1="dk1" bg2="lt2" tx2="dk2" accent1="accent1" accent2="accent2" accent3="accent3" accent4="accent4" accent5="accent5" accent6="accent6" hlink="hlink" folHlink="folHlink"/>
   <p:sldLayoutIdLst>
-    <p:sldLayoutId xmlns:r="http://schemas.openxmlformats.org/officeDocument/2006/relationships" id="2147483649" r:id="R9906132b5c65440b"/>
+    <p:sldLayoutId xmlns:r="http://schemas.openxmlformats.org/officeDocument/2006/relationships" id="2147483649" r:id="Rc98f2d47c72445ba"/>
   </p:sldLayoutIdLst>
   <p:txStyles>
     <p:titleStyle>
@@ -1864,7 +1864,7 @@
           <p:nvPr/>
         </p:nvPicPr>
         <p:blipFill>
-          <a:blip xmlns:r="http://schemas.openxmlformats.org/officeDocument/2006/relationships" xmlns:a="http://schemas.openxmlformats.org/drawingml/2006/main" r:embed="R0bb77b4e910b437b"/>
+          <a:blip xmlns:r="http://schemas.openxmlformats.org/officeDocument/2006/relationships" xmlns:a="http://schemas.openxmlformats.org/drawingml/2006/main" r:embed="Rb0249a2706e14e09"/>
           <a:srcRect xmlns:a="http://schemas.openxmlformats.org/drawingml/2006/main" l="65000" t="0" r="0" b="0"/>
           <a:stretch xmlns:a="http://schemas.openxmlformats.org/drawingml/2006/main">
             <a:fillRect l="0" t="0" r="0" b="0"/>
@@ -2303,7 +2303,7 @@
           <p:nvPr/>
         </p:nvPicPr>
         <p:blipFill>
-          <a:blip xmlns:r="http://schemas.openxmlformats.org/officeDocument/2006/relationships" xmlns:a="http://schemas.openxmlformats.org/drawingml/2006/main" r:embed="R75659b9cd7cd4baa"/>
+          <a:blip xmlns:r="http://schemas.openxmlformats.org/officeDocument/2006/relationships" xmlns:a="http://schemas.openxmlformats.org/drawingml/2006/main" r:embed="R46b0ba073f604a83"/>
           <a:srcRect xmlns:a="http://schemas.openxmlformats.org/drawingml/2006/main" l="65000" t="0" r="0" b="0"/>
           <a:stretch xmlns:a="http://schemas.openxmlformats.org/drawingml/2006/main">
             <a:fillRect l="0" t="0" r="0" b="0"/>
@@ -3407,7 +3407,7 @@
           <p:nvPr/>
         </p:nvPicPr>
         <p:blipFill>
-          <a:blip xmlns:r="http://schemas.openxmlformats.org/officeDocument/2006/relationships" xmlns:a="http://schemas.openxmlformats.org/drawingml/2006/main" r:embed="R72a69dfa2eab42ab"/>
+          <a:blip xmlns:r="http://schemas.openxmlformats.org/officeDocument/2006/relationships" xmlns:a="http://schemas.openxmlformats.org/drawingml/2006/main" r:embed="Rf2a00c94d75540cf"/>
           <a:srcRect xmlns:a="http://schemas.openxmlformats.org/drawingml/2006/main" l="0" t="10366" r="0" b="10366"/>
           <a:stretch xmlns:a="http://schemas.openxmlformats.org/drawingml/2006/main">
             <a:fillRect l="0" t="0" r="0" b="0"/>
@@ -4438,7 +4438,7 @@
           <p:nvPr/>
         </p:nvPicPr>
         <p:blipFill>
-          <a:blip xmlns:r="http://schemas.openxmlformats.org/officeDocument/2006/relationships" xmlns:a="http://schemas.openxmlformats.org/drawingml/2006/main" r:embed="R8f934fbbea3e4345"/>
+          <a:blip xmlns:r="http://schemas.openxmlformats.org/officeDocument/2006/relationships" xmlns:a="http://schemas.openxmlformats.org/drawingml/2006/main" r:embed="R0842705fbf954356"/>
           <a:srcRect xmlns:a="http://schemas.openxmlformats.org/drawingml/2006/main" l="0" t="6924" r="0" b="6924"/>
           <a:stretch xmlns:a="http://schemas.openxmlformats.org/drawingml/2006/main">
             <a:fillRect l="0" t="0" r="0" b="0"/>
@@ -7659,7 +7659,7 @@
           <p:nvPr/>
         </p:nvPicPr>
         <p:blipFill>
-          <a:blip xmlns:r="http://schemas.openxmlformats.org/officeDocument/2006/relationships" xmlns:a="http://schemas.openxmlformats.org/drawingml/2006/main" r:embed="R5c738a9e02c546f3"/>
+          <a:blip xmlns:r="http://schemas.openxmlformats.org/officeDocument/2006/relationships" xmlns:a="http://schemas.openxmlformats.org/drawingml/2006/main" r:embed="R2b85b12b26404be1"/>
           <a:srcRect xmlns:a="http://schemas.openxmlformats.org/drawingml/2006/main" l="0" t="51" r="0" b="51"/>
           <a:stretch xmlns:a="http://schemas.openxmlformats.org/drawingml/2006/main">
             <a:fillRect l="0" t="0" r="0" b="0"/>
@@ -9548,7 +9548,7 @@
           <p:nvPr/>
         </p:nvPicPr>
         <p:blipFill>
-          <a:blip xmlns:r="http://schemas.openxmlformats.org/officeDocument/2006/relationships" xmlns:a="http://schemas.openxmlformats.org/drawingml/2006/main" r:embed="Rc1738b4375ed4339"/>
+          <a:blip xmlns:r="http://schemas.openxmlformats.org/officeDocument/2006/relationships" xmlns:a="http://schemas.openxmlformats.org/drawingml/2006/main" r:embed="R67287c4d90fc4bd9"/>
           <a:srcRect xmlns:a="http://schemas.openxmlformats.org/drawingml/2006/main" l="0" t="3275" r="0" b="3275"/>
           <a:stretch xmlns:a="http://schemas.openxmlformats.org/drawingml/2006/main">
             <a:fillRect l="0" t="0" r="0" b="0"/>

</xml_diff>